<commit_message>
docs(demo): add PDF version of the deck and refresh slide details (EKS 1.36, node type, EBS policy)
</commit_message>
<xml_diff>
--- a/demo/slides.pptx
+++ b/demo/slides.pptx
@@ -3701,7 +3701,7 @@
                 </a:solidFill>
                 <a:latin typeface="Calibri"/>
               </a:rPr>
-              <a:t>PVCs on EKS need the EBS CSI driver (plus IRSA)</a:t>
+              <a:t>PVCs on EKS need the EBS CSI driver add-on</a:t>
             </a:r>
           </a:p>
           <a:p>
@@ -9248,7 +9248,7 @@
                 </a:solidFill>
                 <a:latin typeface="Calibri"/>
               </a:rPr>
-              <a:t>~$0.25 / hour — cluster destroyed after the demo</a:t>
+              <a:t>~$0.35 / hour — cluster destroyed after the demo</a:t>
             </a:r>
           </a:p>
         </p:txBody>
@@ -9323,7 +9323,7 @@
                 </a:solidFill>
                 <a:latin typeface="Calibri"/>
               </a:rPr>
-              <a:t>EKS 1.34, managed node group</a:t>
+              <a:t>EKS 1.36, managed node group</a:t>
             </a:r>
           </a:p>
           <a:p>
@@ -9340,7 +9340,7 @@
                 </a:solidFill>
                 <a:latin typeface="Calibri"/>
               </a:rPr>
-              <a:t>m7i-flex.large × 2 (min 2, max 3)</a:t>
+              <a:t>m7i-flex.large × 2 (min 2, max 2)</a:t>
             </a:r>
           </a:p>
           <a:p>
@@ -9374,7 +9374,7 @@
                 </a:solidFill>
                 <a:latin typeface="Calibri"/>
               </a:rPr>
-              <a:t>aws-ebs-csi-driver with IRSA — backs PostgreSQL PVC</a:t>
+              <a:t>aws-ebs-csi-driver (EBS policy on the node role) — backs PostgreSQL PVC</a:t>
             </a:r>
           </a:p>
         </p:txBody>

</xml_diff>

<commit_message>
docs: regenerate slides and local screenshots under the InvenPilot name
</commit_message>
<xml_diff>
--- a/demo/slides.pptx
+++ b/demo/slides.pptx
@@ -3215,7 +3215,7 @@
                 </a:solidFill>
                 <a:latin typeface="Calibri"/>
               </a:rPr>
-              <a:t>StockPilot — Inventory Management</a:t>
+              <a:t>InvenPilot — Inventory Management</a:t>
             </a:r>
           </a:p>
         </p:txBody>
@@ -3285,7 +3285,7 @@
                 </a:solidFill>
                 <a:latin typeface="Calibri"/>
               </a:rPr>
-              <a:t>github.com/Gaurakumar-s/stockpilot-devsecops</a:t>
+              <a:t>github.com/Gaurakumar-s/invenpilot-devsecops</a:t>
             </a:r>
           </a:p>
         </p:txBody>
@@ -3540,7 +3540,7 @@
                 </a:solidFill>
                 <a:latin typeface="Calibri"/>
               </a:rPr>
-              <a:t>StockPilot · DevSecOps Final Capstone · Gaurav Kumar</a:t>
+              <a:t>InvenPilot · DevSecOps Final Capstone · Gaurav Kumar</a:t>
             </a:r>
           </a:p>
         </p:txBody>
@@ -4082,7 +4082,7 @@
                 </a:solidFill>
                 <a:latin typeface="Calibri"/>
               </a:rPr>
-              <a:t>Thank you  ·  github.com/Gaurakumar-s/stockpilot-devsecops</a:t>
+              <a:t>Thank you  ·  github.com/Gaurakumar-s/invenpilot-devsecops</a:t>
             </a:r>
           </a:p>
           <a:p>
@@ -4094,7 +4094,7 @@
                 </a:solidFill>
                 <a:latin typeface="Calibri"/>
               </a:rPr>
-              <a:t>StockPilot — DevSecOps Final Capstone · Gaurav Kumar</a:t>
+              <a:t>InvenPilot — DevSecOps Final Capstone · Gaurav Kumar</a:t>
             </a:r>
           </a:p>
         </p:txBody>
@@ -4270,7 +4270,7 @@
                 </a:solidFill>
                 <a:latin typeface="Calibri"/>
               </a:rPr>
-              <a:t>StockPilot · DevSecOps Final Capstone · Gaurav Kumar</a:t>
+              <a:t>InvenPilot · DevSecOps Final Capstone · Gaurav Kumar</a:t>
             </a:r>
           </a:p>
         </p:txBody>
@@ -4986,7 +4986,7 @@
                 </a:solidFill>
                 <a:latin typeface="Calibri"/>
               </a:rPr>
-              <a:t>StockPilot · DevSecOps Final Capstone · Gaurav Kumar</a:t>
+              <a:t>InvenPilot · DevSecOps Final Capstone · Gaurav Kumar</a:t>
             </a:r>
           </a:p>
         </p:txBody>
@@ -6013,7 +6013,7 @@
                 </a:solidFill>
                 <a:latin typeface="Calibri"/>
               </a:rPr>
-              <a:t>StockPilot · DevSecOps Final Capstone · Gaurav Kumar</a:t>
+              <a:t>InvenPilot · DevSecOps Final Capstone · Gaurav Kumar</a:t>
             </a:r>
           </a:p>
         </p:txBody>
@@ -6574,7 +6574,7 @@
                 </a:solidFill>
                 <a:latin typeface="Calibri"/>
               </a:rPr>
-              <a:t>AWS EKS  —  Terraform-provisioned VPC (2 public + 2 private subnets, NAT)   ·   namespace: stockpilot</a:t>
+              <a:t>AWS EKS  —  Terraform-provisioned VPC (2 public + 2 private subnets, NAT)   ·   namespace: invenpilot</a:t>
             </a:r>
           </a:p>
         </p:txBody>
@@ -7144,7 +7144,7 @@
                 </a:solidFill>
                 <a:latin typeface="Calibri"/>
               </a:rPr>
-              <a:t>StockPilot dashboard</a:t>
+              <a:t>InvenPilot dashboard</a:t>
             </a:r>
           </a:p>
         </p:txBody>
@@ -7569,7 +7569,7 @@
                 </a:solidFill>
                 <a:latin typeface="Calibri"/>
               </a:rPr>
-              <a:t>StockPilot · DevSecOps Final Capstone · Gaurav Kumar</a:t>
+              <a:t>InvenPilot · DevSecOps Final Capstone · Gaurav Kumar</a:t>
             </a:r>
           </a:p>
         </p:txBody>
@@ -8063,7 +8063,7 @@
                 </a:solidFill>
                 <a:latin typeface="Calibri"/>
               </a:rPr>
-              <a:t>write SHA into helm/stockpilot/values.yaml</a:t>
+              <a:t>write SHA into helm/invenpilot/values.yaml</a:t>
             </a:r>
           </a:p>
           <a:p>
@@ -8132,7 +8132,7 @@
                 </a:solidFill>
                 <a:latin typeface="Calibri"/>
               </a:rPr>
-              <a:t>Images: ghcr.io/gaurakumar-s/stockpilot-backend:&lt;git-sha&gt; and stockpilot-frontend:&lt;git-sha&gt; — no "latest" tag</a:t>
+              <a:t>Images: ghcr.io/gaurakumar-s/invenpilot-backend:&lt;git-sha&gt; and invenpilot-frontend:&lt;git-sha&gt; — no "latest" tag</a:t>
             </a:r>
           </a:p>
           <a:p>
@@ -8359,7 +8359,7 @@
                 </a:solidFill>
                 <a:latin typeface="Calibri"/>
               </a:rPr>
-              <a:t>StockPilot · DevSecOps Final Capstone · Gaurav Kumar</a:t>
+              <a:t>InvenPilot · DevSecOps Final Capstone · Gaurav Kumar</a:t>
             </a:r>
           </a:p>
         </p:txBody>
@@ -8978,7 +8978,7 @@
                 </a:solidFill>
                 <a:latin typeface="Calibri"/>
               </a:rPr>
-              <a:t>StockPilot · DevSecOps Final Capstone · Gaurav Kumar</a:t>
+              <a:t>InvenPilot · DevSecOps Final Capstone · Gaurav Kumar</a:t>
             </a:r>
           </a:p>
         </p:txBody>
@@ -9778,7 +9778,7 @@
                 </a:solidFill>
                 <a:latin typeface="Calibri"/>
               </a:rPr>
-              <a:t>StockPilot · DevSecOps Final Capstone · Gaurav Kumar</a:t>
+              <a:t>InvenPilot · DevSecOps Final Capstone · Gaurav Kumar</a:t>
             </a:r>
           </a:p>
         </p:txBody>
@@ -9848,7 +9848,7 @@
                 </a:solidFill>
                 <a:latin typeface="Calibri"/>
               </a:rPr>
-              <a:t>Helm chart — helm/stockpilot</a:t>
+              <a:t>Helm chart — helm/invenpilot</a:t>
             </a:r>
           </a:p>
         </p:txBody>
@@ -10180,7 +10180,7 @@
                 </a:solidFill>
                 <a:latin typeface="Menlo"/>
               </a:rPr>
-              <a:t>$ kubectl get pods,svc,ingress -n stockpilot</a:t>
+              <a:t>$ kubectl get pods,svc,ingress -n invenpilot</a:t>
             </a:r>
           </a:p>
           <a:p>
@@ -10192,7 +10192,7 @@
                 </a:solidFill>
                 <a:latin typeface="Menlo"/>
               </a:rPr>
-              <a:t>$ helm list -n stockpilot</a:t>
+              <a:t>$ helm list -n invenpilot</a:t>
             </a:r>
           </a:p>
           <a:p>
@@ -10204,7 +10204,7 @@
                 </a:solidFill>
                 <a:latin typeface="Menlo"/>
               </a:rPr>
-              <a:t>$ kubectl get hpa -n stockpilot</a:t>
+              <a:t>$ kubectl get hpa -n invenpilot</a:t>
             </a:r>
           </a:p>
           <a:p>
@@ -10216,7 +10216,7 @@
                 </a:solidFill>
                 <a:latin typeface="Menlo"/>
               </a:rPr>
-              <a:t>$ argocd app get stockpilot</a:t>
+              <a:t>$ argocd app get invenpilot</a:t>
             </a:r>
           </a:p>
         </p:txBody>
@@ -10392,7 +10392,7 @@
                 </a:solidFill>
                 <a:latin typeface="Calibri"/>
               </a:rPr>
-              <a:t>StockPilot · DevSecOps Final Capstone · Gaurav Kumar</a:t>
+              <a:t>InvenPilot · DevSecOps Final Capstone · Gaurav Kumar</a:t>
             </a:r>
           </a:p>
         </p:txBody>
@@ -10950,7 +10950,7 @@
                 </a:solidFill>
                 <a:latin typeface="Calibri"/>
               </a:rPr>
-              <a:t>Grafana — "StockPilot — Application Metrics"</a:t>
+              <a:t>Grafana — "InvenPilot — Application Metrics"</a:t>
             </a:r>
           </a:p>
         </p:txBody>

</xml_diff>

<commit_message>
docs(demo): add four full-size evidence slides to the deck (14 slides)
</commit_message>
<xml_diff>
--- a/demo/slides.pptx
+++ b/demo/slides.pptx
@@ -15,6 +15,10 @@
     <p:sldId id="263" r:id="rId14"/>
     <p:sldId id="264" r:id="rId15"/>
     <p:sldId id="265" r:id="rId16"/>
+    <p:sldId id="266" r:id="rId17"/>
+    <p:sldId id="267" r:id="rId18"/>
+    <p:sldId id="268" r:id="rId19"/>
+    <p:sldId id="269" r:id="rId20"/>
   </p:sldIdLst>
   <p:sldSz cx="12191695" cy="6858000" type="screen4x3"/>
   <p:notesSz cx="6858000" cy="9144000"/>
@@ -3575,7 +3579,7 @@
                 </a:solidFill>
                 <a:latin typeface="Calibri"/>
               </a:rPr>
-              <a:t>10 / 10</a:t>
+              <a:t>10 / 14</a:t>
             </a:r>
           </a:p>
         </p:txBody>
@@ -4095,6 +4099,906 @@
                 <a:latin typeface="Calibri"/>
               </a:rPr>
               <a:t>InvenPilot — DevSecOps Final Capstone · Gaurav Kumar</a:t>
+            </a:r>
+          </a:p>
+        </p:txBody>
+      </p:sp>
+    </p:spTree>
+  </p:cSld>
+  <p:clrMapOvr>
+    <a:masterClrMapping/>
+  </p:clrMapOvr>
+</p:sld>
+</file>
+
+<file path=ppt/slides/slide11.xml><?xml version="1.0" encoding="utf-8"?>
+<p:sld xmlns:a="http://schemas.openxmlformats.org/drawingml/2006/main" xmlns:p="http://schemas.openxmlformats.org/presentationml/2006/main" xmlns:r="http://schemas.openxmlformats.org/officeDocument/2006/relationships">
+  <p:cSld>
+    <p:spTree>
+      <p:nvGrpSpPr>
+        <p:cNvPr id="1" name=""/>
+        <p:cNvGrpSpPr/>
+        <p:nvPr/>
+      </p:nvGrpSpPr>
+      <p:grpSpPr/>
+      <p:sp>
+        <p:nvSpPr>
+          <p:cNvPr id="2" name="Rectangle 1"/>
+          <p:cNvSpPr/>
+          <p:nvPr/>
+        </p:nvSpPr>
+        <p:spPr>
+          <a:xfrm>
+            <a:off x="0" y="0"/>
+            <a:ext cx="12191695" cy="914400"/>
+          </a:xfrm>
+          <a:prstGeom prst="rect">
+            <a:avLst/>
+          </a:prstGeom>
+          <a:solidFill>
+            <a:srgbClr val="0F172A"/>
+          </a:solidFill>
+          <a:ln>
+            <a:noFill/>
+          </a:ln>
+        </p:spPr>
+        <p:style>
+          <a:lnRef idx="1">
+            <a:schemeClr val="accent1"/>
+          </a:lnRef>
+          <a:fillRef idx="3">
+            <a:schemeClr val="accent1"/>
+          </a:fillRef>
+          <a:effectRef idx="2">
+            <a:schemeClr val="accent1"/>
+          </a:effectRef>
+          <a:fontRef idx="minor">
+            <a:schemeClr val="lt1"/>
+          </a:fontRef>
+        </p:style>
+        <p:txBody>
+          <a:bodyPr rtlCol="0" anchor="ctr"/>
+          <a:lstStyle/>
+          <a:p>
+            <a:r>
+              <a:rPr sz="2800" b="1">
+                <a:solidFill>
+                  <a:srgbClr val="FFFFFF"/>
+                </a:solidFill>
+              </a:rPr>
+              <a:t>Evidence — CI/CD run and registry</a:t>
+            </a:r>
+          </a:p>
+        </p:txBody>
+      </p:sp>
+      <p:sp>
+        <p:nvSpPr>
+          <p:cNvPr id="3" name="Rectangle 2"/>
+          <p:cNvSpPr/>
+          <p:nvPr/>
+        </p:nvSpPr>
+        <p:spPr>
+          <a:xfrm>
+            <a:off x="0" y="914400"/>
+            <a:ext cx="12191695" cy="54864"/>
+          </a:xfrm>
+          <a:prstGeom prst="rect">
+            <a:avLst/>
+          </a:prstGeom>
+          <a:solidFill>
+            <a:srgbClr val="2563EB"/>
+          </a:solidFill>
+          <a:ln>
+            <a:noFill/>
+          </a:ln>
+        </p:spPr>
+        <p:style>
+          <a:lnRef idx="1">
+            <a:schemeClr val="accent1"/>
+          </a:lnRef>
+          <a:fillRef idx="3">
+            <a:schemeClr val="accent1"/>
+          </a:fillRef>
+          <a:effectRef idx="2">
+            <a:schemeClr val="accent1"/>
+          </a:effectRef>
+          <a:fontRef idx="minor">
+            <a:schemeClr val="lt1"/>
+          </a:fontRef>
+        </p:style>
+        <p:txBody>
+          <a:bodyPr rtlCol="0" anchor="ctr"/>
+          <a:lstStyle/>
+          <a:p>
+            <a:pPr algn="ctr"/>
+          </a:p>
+        </p:txBody>
+      </p:sp>
+      <p:pic>
+        <p:nvPicPr>
+          <p:cNvPr id="4" name="Picture 3" descr="09-actions-green.png"/>
+          <p:cNvPicPr>
+            <a:picLocks noChangeAspect="1"/>
+          </p:cNvPicPr>
+          <p:nvPr/>
+        </p:nvPicPr>
+        <p:blipFill>
+          <a:blip r:embed="rId2"/>
+          <a:stretch>
+            <a:fillRect/>
+          </a:stretch>
+        </p:blipFill>
+        <p:spPr>
+          <a:xfrm>
+            <a:off x="365760" y="1188720"/>
+            <a:ext cx="5615787" cy="3899852"/>
+          </a:xfrm>
+          <a:prstGeom prst="rect">
+            <a:avLst/>
+          </a:prstGeom>
+        </p:spPr>
+      </p:pic>
+      <p:pic>
+        <p:nvPicPr>
+          <p:cNvPr id="5" name="Picture 4" descr="10-ghcr-packages-sha.png"/>
+          <p:cNvPicPr>
+            <a:picLocks noChangeAspect="1"/>
+          </p:cNvPicPr>
+          <p:nvPr/>
+        </p:nvPicPr>
+        <p:blipFill>
+          <a:blip r:embed="rId3"/>
+          <a:stretch>
+            <a:fillRect/>
+          </a:stretch>
+        </p:blipFill>
+        <p:spPr>
+          <a:xfrm>
+            <a:off x="6210147" y="1188720"/>
+            <a:ext cx="5615787" cy="3652172"/>
+          </a:xfrm>
+          <a:prstGeom prst="rect">
+            <a:avLst/>
+          </a:prstGeom>
+        </p:spPr>
+      </p:pic>
+      <p:sp>
+        <p:nvSpPr>
+          <p:cNvPr id="6" name="TextBox 5"/>
+          <p:cNvSpPr txBox="1"/>
+          <p:nvPr/>
+        </p:nvSpPr>
+        <p:spPr>
+          <a:xfrm>
+            <a:off x="365760" y="6172200"/>
+            <a:ext cx="11460175" cy="457200"/>
+          </a:xfrm>
+          <a:prstGeom prst="rect">
+            <a:avLst/>
+          </a:prstGeom>
+          <a:noFill/>
+        </p:spPr>
+        <p:txBody>
+          <a:bodyPr wrap="none">
+            <a:spAutoFit/>
+          </a:bodyPr>
+          <a:lstStyle/>
+          <a:p>
+            <a:r>
+              <a:rPr sz="1400">
+                <a:solidFill>
+                  <a:srgbClr val="475569"/>
+                </a:solidFill>
+              </a:rPr>
+              <a:t>Left: one push, four green jobs. Right: GHCR package tagged only with commit SHAs.</a:t>
+            </a:r>
+          </a:p>
+        </p:txBody>
+      </p:sp>
+      <p:sp>
+        <p:nvSpPr>
+          <p:cNvPr id="7" name="TextBox 6"/>
+          <p:cNvSpPr txBox="1"/>
+          <p:nvPr/>
+        </p:nvSpPr>
+        <p:spPr>
+          <a:xfrm>
+            <a:off x="365760" y="6446520"/>
+            <a:ext cx="11460175" cy="320040"/>
+          </a:xfrm>
+          <a:prstGeom prst="rect">
+            <a:avLst/>
+          </a:prstGeom>
+          <a:noFill/>
+        </p:spPr>
+        <p:txBody>
+          <a:bodyPr wrap="none">
+            <a:spAutoFit/>
+          </a:bodyPr>
+          <a:lstStyle/>
+          <a:p>
+            <a:r>
+              <a:rPr sz="1100">
+                <a:solidFill>
+                  <a:srgbClr val="94A3B8"/>
+                </a:solidFill>
+              </a:rPr>
+              <a:t>InvenPilot · DevSecOps Final Capstone · Gaurav Kumar          11 / 14</a:t>
+            </a:r>
+          </a:p>
+        </p:txBody>
+      </p:sp>
+    </p:spTree>
+  </p:cSld>
+  <p:clrMapOvr>
+    <a:masterClrMapping/>
+  </p:clrMapOvr>
+</p:sld>
+</file>
+
+<file path=ppt/slides/slide12.xml><?xml version="1.0" encoding="utf-8"?>
+<p:sld xmlns:a="http://schemas.openxmlformats.org/drawingml/2006/main" xmlns:p="http://schemas.openxmlformats.org/presentationml/2006/main" xmlns:r="http://schemas.openxmlformats.org/officeDocument/2006/relationships">
+  <p:cSld>
+    <p:spTree>
+      <p:nvGrpSpPr>
+        <p:cNvPr id="1" name=""/>
+        <p:cNvGrpSpPr/>
+        <p:nvPr/>
+      </p:nvGrpSpPr>
+      <p:grpSpPr/>
+      <p:sp>
+        <p:nvSpPr>
+          <p:cNvPr id="2" name="Rectangle 1"/>
+          <p:cNvSpPr/>
+          <p:nvPr/>
+        </p:nvSpPr>
+        <p:spPr>
+          <a:xfrm>
+            <a:off x="0" y="0"/>
+            <a:ext cx="12191695" cy="914400"/>
+          </a:xfrm>
+          <a:prstGeom prst="rect">
+            <a:avLst/>
+          </a:prstGeom>
+          <a:solidFill>
+            <a:srgbClr val="0F172A"/>
+          </a:solidFill>
+          <a:ln>
+            <a:noFill/>
+          </a:ln>
+        </p:spPr>
+        <p:style>
+          <a:lnRef idx="1">
+            <a:schemeClr val="accent1"/>
+          </a:lnRef>
+          <a:fillRef idx="3">
+            <a:schemeClr val="accent1"/>
+          </a:fillRef>
+          <a:effectRef idx="2">
+            <a:schemeClr val="accent1"/>
+          </a:effectRef>
+          <a:fontRef idx="minor">
+            <a:schemeClr val="lt1"/>
+          </a:fontRef>
+        </p:style>
+        <p:txBody>
+          <a:bodyPr rtlCol="0" anchor="ctr"/>
+          <a:lstStyle/>
+          <a:p>
+            <a:r>
+              <a:rPr sz="2800" b="1">
+                <a:solidFill>
+                  <a:srgbClr val="FFFFFF"/>
+                </a:solidFill>
+              </a:rPr>
+              <a:t>Evidence — Terraform on AWS</a:t>
+            </a:r>
+          </a:p>
+        </p:txBody>
+      </p:sp>
+      <p:sp>
+        <p:nvSpPr>
+          <p:cNvPr id="3" name="Rectangle 2"/>
+          <p:cNvSpPr/>
+          <p:nvPr/>
+        </p:nvSpPr>
+        <p:spPr>
+          <a:xfrm>
+            <a:off x="0" y="914400"/>
+            <a:ext cx="12191695" cy="54864"/>
+          </a:xfrm>
+          <a:prstGeom prst="rect">
+            <a:avLst/>
+          </a:prstGeom>
+          <a:solidFill>
+            <a:srgbClr val="2563EB"/>
+          </a:solidFill>
+          <a:ln>
+            <a:noFill/>
+          </a:ln>
+        </p:spPr>
+        <p:style>
+          <a:lnRef idx="1">
+            <a:schemeClr val="accent1"/>
+          </a:lnRef>
+          <a:fillRef idx="3">
+            <a:schemeClr val="accent1"/>
+          </a:fillRef>
+          <a:effectRef idx="2">
+            <a:schemeClr val="accent1"/>
+          </a:effectRef>
+          <a:fontRef idx="minor">
+            <a:schemeClr val="lt1"/>
+          </a:fontRef>
+        </p:style>
+        <p:txBody>
+          <a:bodyPr rtlCol="0" anchor="ctr"/>
+          <a:lstStyle/>
+          <a:p>
+            <a:pPr algn="ctr"/>
+          </a:p>
+        </p:txBody>
+      </p:sp>
+      <p:pic>
+        <p:nvPicPr>
+          <p:cNvPr id="4" name="Picture 3" descr="13-aws-vpc.png"/>
+          <p:cNvPicPr>
+            <a:picLocks noChangeAspect="1"/>
+          </p:cNvPicPr>
+          <p:nvPr/>
+        </p:nvPicPr>
+        <p:blipFill>
+          <a:blip r:embed="rId2"/>
+          <a:stretch>
+            <a:fillRect/>
+          </a:stretch>
+        </p:blipFill>
+        <p:spPr>
+          <a:xfrm>
+            <a:off x="365760" y="1188720"/>
+            <a:ext cx="5615787" cy="3652172"/>
+          </a:xfrm>
+          <a:prstGeom prst="rect">
+            <a:avLst/>
+          </a:prstGeom>
+        </p:spPr>
+      </p:pic>
+      <p:pic>
+        <p:nvPicPr>
+          <p:cNvPr id="5" name="Picture 4" descr="14-aws-eks-cli.png"/>
+          <p:cNvPicPr>
+            <a:picLocks noChangeAspect="1"/>
+          </p:cNvPicPr>
+          <p:nvPr/>
+        </p:nvPicPr>
+        <p:blipFill>
+          <a:blip r:embed="rId3"/>
+          <a:stretch>
+            <a:fillRect/>
+          </a:stretch>
+        </p:blipFill>
+        <p:spPr>
+          <a:xfrm>
+            <a:off x="6210147" y="1188720"/>
+            <a:ext cx="5615787" cy="4043367"/>
+          </a:xfrm>
+          <a:prstGeom prst="rect">
+            <a:avLst/>
+          </a:prstGeom>
+        </p:spPr>
+      </p:pic>
+      <p:sp>
+        <p:nvSpPr>
+          <p:cNvPr id="6" name="TextBox 5"/>
+          <p:cNvSpPr txBox="1"/>
+          <p:nvPr/>
+        </p:nvSpPr>
+        <p:spPr>
+          <a:xfrm>
+            <a:off x="365760" y="6172200"/>
+            <a:ext cx="11460175" cy="457200"/>
+          </a:xfrm>
+          <a:prstGeom prst="rect">
+            <a:avLst/>
+          </a:prstGeom>
+          <a:noFill/>
+        </p:spPr>
+        <p:txBody>
+          <a:bodyPr wrap="none">
+            <a:spAutoFit/>
+          </a:bodyPr>
+          <a:lstStyle/>
+          <a:p>
+            <a:r>
+              <a:rPr sz="1400">
+                <a:solidFill>
+                  <a:srgbClr val="475569"/>
+                </a:solidFill>
+              </a:rPr>
+              <a:t>Left: the VPC in the AWS console (ap-southeast-2). Right: EKS cluster, node group and EC2 nodes from terraform apply.</a:t>
+            </a:r>
+          </a:p>
+        </p:txBody>
+      </p:sp>
+      <p:sp>
+        <p:nvSpPr>
+          <p:cNvPr id="7" name="TextBox 6"/>
+          <p:cNvSpPr txBox="1"/>
+          <p:nvPr/>
+        </p:nvSpPr>
+        <p:spPr>
+          <a:xfrm>
+            <a:off x="365760" y="6446520"/>
+            <a:ext cx="11460175" cy="320040"/>
+          </a:xfrm>
+          <a:prstGeom prst="rect">
+            <a:avLst/>
+          </a:prstGeom>
+          <a:noFill/>
+        </p:spPr>
+        <p:txBody>
+          <a:bodyPr wrap="none">
+            <a:spAutoFit/>
+          </a:bodyPr>
+          <a:lstStyle/>
+          <a:p>
+            <a:r>
+              <a:rPr sz="1100">
+                <a:solidFill>
+                  <a:srgbClr val="94A3B8"/>
+                </a:solidFill>
+              </a:rPr>
+              <a:t>InvenPilot · DevSecOps Final Capstone · Gaurav Kumar          12 / 14</a:t>
+            </a:r>
+          </a:p>
+        </p:txBody>
+      </p:sp>
+    </p:spTree>
+  </p:cSld>
+  <p:clrMapOvr>
+    <a:masterClrMapping/>
+  </p:clrMapOvr>
+</p:sld>
+</file>
+
+<file path=ppt/slides/slide13.xml><?xml version="1.0" encoding="utf-8"?>
+<p:sld xmlns:a="http://schemas.openxmlformats.org/drawingml/2006/main" xmlns:p="http://schemas.openxmlformats.org/presentationml/2006/main" xmlns:r="http://schemas.openxmlformats.org/officeDocument/2006/relationships">
+  <p:cSld>
+    <p:spTree>
+      <p:nvGrpSpPr>
+        <p:cNvPr id="1" name=""/>
+        <p:cNvGrpSpPr/>
+        <p:nvPr/>
+      </p:nvGrpSpPr>
+      <p:grpSpPr/>
+      <p:sp>
+        <p:nvSpPr>
+          <p:cNvPr id="2" name="Rectangle 1"/>
+          <p:cNvSpPr/>
+          <p:nvPr/>
+        </p:nvSpPr>
+        <p:spPr>
+          <a:xfrm>
+            <a:off x="0" y="0"/>
+            <a:ext cx="12191695" cy="914400"/>
+          </a:xfrm>
+          <a:prstGeom prst="rect">
+            <a:avLst/>
+          </a:prstGeom>
+          <a:solidFill>
+            <a:srgbClr val="0F172A"/>
+          </a:solidFill>
+          <a:ln>
+            <a:noFill/>
+          </a:ln>
+        </p:spPr>
+        <p:style>
+          <a:lnRef idx="1">
+            <a:schemeClr val="accent1"/>
+          </a:lnRef>
+          <a:fillRef idx="3">
+            <a:schemeClr val="accent1"/>
+          </a:fillRef>
+          <a:effectRef idx="2">
+            <a:schemeClr val="accent1"/>
+          </a:effectRef>
+          <a:fontRef idx="minor">
+            <a:schemeClr val="lt1"/>
+          </a:fontRef>
+        </p:style>
+        <p:txBody>
+          <a:bodyPr rtlCol="0" anchor="ctr"/>
+          <a:lstStyle/>
+          <a:p>
+            <a:r>
+              <a:rPr sz="2800" b="1">
+                <a:solidFill>
+                  <a:srgbClr val="FFFFFF"/>
+                </a:solidFill>
+              </a:rPr>
+              <a:t>Evidence — Kubernetes, Helm and ArgoCD</a:t>
+            </a:r>
+          </a:p>
+        </p:txBody>
+      </p:sp>
+      <p:sp>
+        <p:nvSpPr>
+          <p:cNvPr id="3" name="Rectangle 2"/>
+          <p:cNvSpPr/>
+          <p:nvPr/>
+        </p:nvSpPr>
+        <p:spPr>
+          <a:xfrm>
+            <a:off x="0" y="914400"/>
+            <a:ext cx="12191695" cy="54864"/>
+          </a:xfrm>
+          <a:prstGeom prst="rect">
+            <a:avLst/>
+          </a:prstGeom>
+          <a:solidFill>
+            <a:srgbClr val="2563EB"/>
+          </a:solidFill>
+          <a:ln>
+            <a:noFill/>
+          </a:ln>
+        </p:spPr>
+        <p:style>
+          <a:lnRef idx="1">
+            <a:schemeClr val="accent1"/>
+          </a:lnRef>
+          <a:fillRef idx="3">
+            <a:schemeClr val="accent1"/>
+          </a:fillRef>
+          <a:effectRef idx="2">
+            <a:schemeClr val="accent1"/>
+          </a:effectRef>
+          <a:fontRef idx="minor">
+            <a:schemeClr val="lt1"/>
+          </a:fontRef>
+        </p:style>
+        <p:txBody>
+          <a:bodyPr rtlCol="0" anchor="ctr"/>
+          <a:lstStyle/>
+          <a:p>
+            <a:pPr algn="ctr"/>
+          </a:p>
+        </p:txBody>
+      </p:sp>
+      <p:pic>
+        <p:nvPicPr>
+          <p:cNvPr id="4" name="Picture 3" descr="16-kubectl-get-pods-eks.png"/>
+          <p:cNvPicPr>
+            <a:picLocks noChangeAspect="1"/>
+          </p:cNvPicPr>
+          <p:nvPr/>
+        </p:nvPicPr>
+        <p:blipFill>
+          <a:blip r:embed="rId2"/>
+          <a:stretch>
+            <a:fillRect/>
+          </a:stretch>
+        </p:blipFill>
+        <p:spPr>
+          <a:xfrm>
+            <a:off x="365760" y="1188720"/>
+            <a:ext cx="5615787" cy="2454901"/>
+          </a:xfrm>
+          <a:prstGeom prst="rect">
+            <a:avLst/>
+          </a:prstGeom>
+        </p:spPr>
+      </p:pic>
+      <p:pic>
+        <p:nvPicPr>
+          <p:cNvPr id="5" name="Picture 4" descr="23-argocd-synced-eks.png"/>
+          <p:cNvPicPr>
+            <a:picLocks noChangeAspect="1"/>
+          </p:cNvPicPr>
+          <p:nvPr/>
+        </p:nvPicPr>
+        <p:blipFill>
+          <a:blip r:embed="rId3"/>
+          <a:stretch>
+            <a:fillRect/>
+          </a:stretch>
+        </p:blipFill>
+        <p:spPr>
+          <a:xfrm>
+            <a:off x="6210147" y="1188720"/>
+            <a:ext cx="5615787" cy="3690374"/>
+          </a:xfrm>
+          <a:prstGeom prst="rect">
+            <a:avLst/>
+          </a:prstGeom>
+        </p:spPr>
+      </p:pic>
+      <p:sp>
+        <p:nvSpPr>
+          <p:cNvPr id="6" name="TextBox 5"/>
+          <p:cNvSpPr txBox="1"/>
+          <p:nvPr/>
+        </p:nvSpPr>
+        <p:spPr>
+          <a:xfrm>
+            <a:off x="365760" y="6172200"/>
+            <a:ext cx="11460175" cy="457200"/>
+          </a:xfrm>
+          <a:prstGeom prst="rect">
+            <a:avLst/>
+          </a:prstGeom>
+          <a:noFill/>
+        </p:spPr>
+        <p:txBody>
+          <a:bodyPr wrap="none">
+            <a:spAutoFit/>
+          </a:bodyPr>
+          <a:lstStyle/>
+          <a:p>
+            <a:r>
+              <a:rPr sz="1400">
+                <a:solidFill>
+                  <a:srgbClr val="475569"/>
+                </a:solidFill>
+              </a:rPr>
+              <a:t>Left: 2 backend, 2 frontend and 1 PostgreSQL pod Running on EKS. Right: ArgoCD Synced / Healthy.</a:t>
+            </a:r>
+          </a:p>
+        </p:txBody>
+      </p:sp>
+      <p:sp>
+        <p:nvSpPr>
+          <p:cNvPr id="7" name="TextBox 6"/>
+          <p:cNvSpPr txBox="1"/>
+          <p:nvPr/>
+        </p:nvSpPr>
+        <p:spPr>
+          <a:xfrm>
+            <a:off x="365760" y="6446520"/>
+            <a:ext cx="11460175" cy="320040"/>
+          </a:xfrm>
+          <a:prstGeom prst="rect">
+            <a:avLst/>
+          </a:prstGeom>
+          <a:noFill/>
+        </p:spPr>
+        <p:txBody>
+          <a:bodyPr wrap="none">
+            <a:spAutoFit/>
+          </a:bodyPr>
+          <a:lstStyle/>
+          <a:p>
+            <a:r>
+              <a:rPr sz="1100">
+                <a:solidFill>
+                  <a:srgbClr val="94A3B8"/>
+                </a:solidFill>
+              </a:rPr>
+              <a:t>InvenPilot · DevSecOps Final Capstone · Gaurav Kumar          13 / 14</a:t>
+            </a:r>
+          </a:p>
+        </p:txBody>
+      </p:sp>
+    </p:spTree>
+  </p:cSld>
+  <p:clrMapOvr>
+    <a:masterClrMapping/>
+  </p:clrMapOvr>
+</p:sld>
+</file>
+
+<file path=ppt/slides/slide14.xml><?xml version="1.0" encoding="utf-8"?>
+<p:sld xmlns:a="http://schemas.openxmlformats.org/drawingml/2006/main" xmlns:p="http://schemas.openxmlformats.org/presentationml/2006/main" xmlns:r="http://schemas.openxmlformats.org/officeDocument/2006/relationships">
+  <p:cSld>
+    <p:spTree>
+      <p:nvGrpSpPr>
+        <p:cNvPr id="1" name=""/>
+        <p:cNvGrpSpPr/>
+        <p:nvPr/>
+      </p:nvGrpSpPr>
+      <p:grpSpPr/>
+      <p:sp>
+        <p:nvSpPr>
+          <p:cNvPr id="2" name="Rectangle 1"/>
+          <p:cNvSpPr/>
+          <p:nvPr/>
+        </p:nvSpPr>
+        <p:spPr>
+          <a:xfrm>
+            <a:off x="0" y="0"/>
+            <a:ext cx="12191695" cy="914400"/>
+          </a:xfrm>
+          <a:prstGeom prst="rect">
+            <a:avLst/>
+          </a:prstGeom>
+          <a:solidFill>
+            <a:srgbClr val="0F172A"/>
+          </a:solidFill>
+          <a:ln>
+            <a:noFill/>
+          </a:ln>
+        </p:spPr>
+        <p:style>
+          <a:lnRef idx="1">
+            <a:schemeClr val="accent1"/>
+          </a:lnRef>
+          <a:fillRef idx="3">
+            <a:schemeClr val="accent1"/>
+          </a:fillRef>
+          <a:effectRef idx="2">
+            <a:schemeClr val="accent1"/>
+          </a:effectRef>
+          <a:fontRef idx="minor">
+            <a:schemeClr val="lt1"/>
+          </a:fontRef>
+        </p:style>
+        <p:txBody>
+          <a:bodyPr rtlCol="0" anchor="ctr"/>
+          <a:lstStyle/>
+          <a:p>
+            <a:r>
+              <a:rPr sz="2800" b="1">
+                <a:solidFill>
+                  <a:srgbClr val="FFFFFF"/>
+                </a:solidFill>
+              </a:rPr>
+              <a:t>Evidence — Prometheus and Grafana</a:t>
+            </a:r>
+          </a:p>
+        </p:txBody>
+      </p:sp>
+      <p:sp>
+        <p:nvSpPr>
+          <p:cNvPr id="3" name="Rectangle 2"/>
+          <p:cNvSpPr/>
+          <p:nvPr/>
+        </p:nvSpPr>
+        <p:spPr>
+          <a:xfrm>
+            <a:off x="0" y="914400"/>
+            <a:ext cx="12191695" cy="54864"/>
+          </a:xfrm>
+          <a:prstGeom prst="rect">
+            <a:avLst/>
+          </a:prstGeom>
+          <a:solidFill>
+            <a:srgbClr val="2563EB"/>
+          </a:solidFill>
+          <a:ln>
+            <a:noFill/>
+          </a:ln>
+        </p:spPr>
+        <p:style>
+          <a:lnRef idx="1">
+            <a:schemeClr val="accent1"/>
+          </a:lnRef>
+          <a:fillRef idx="3">
+            <a:schemeClr val="accent1"/>
+          </a:fillRef>
+          <a:effectRef idx="2">
+            <a:schemeClr val="accent1"/>
+          </a:effectRef>
+          <a:fontRef idx="minor">
+            <a:schemeClr val="lt1"/>
+          </a:fontRef>
+        </p:style>
+        <p:txBody>
+          <a:bodyPr rtlCol="0" anchor="ctr"/>
+          <a:lstStyle/>
+          <a:p>
+            <a:pPr algn="ctr"/>
+          </a:p>
+        </p:txBody>
+      </p:sp>
+      <p:pic>
+        <p:nvPicPr>
+          <p:cNvPr id="4" name="Picture 3" descr="21-prometheus-targets-up-eks.png"/>
+          <p:cNvPicPr>
+            <a:picLocks noChangeAspect="1"/>
+          </p:cNvPicPr>
+          <p:nvPr/>
+        </p:nvPicPr>
+        <p:blipFill>
+          <a:blip r:embed="rId2"/>
+          <a:stretch>
+            <a:fillRect/>
+          </a:stretch>
+        </p:blipFill>
+        <p:spPr>
+          <a:xfrm>
+            <a:off x="365760" y="1188720"/>
+            <a:ext cx="5615787" cy="3509867"/>
+          </a:xfrm>
+          <a:prstGeom prst="rect">
+            <a:avLst/>
+          </a:prstGeom>
+        </p:spPr>
+      </p:pic>
+      <p:pic>
+        <p:nvPicPr>
+          <p:cNvPr id="5" name="Picture 4" descr="22-grafana-dashboard-eks.png"/>
+          <p:cNvPicPr>
+            <a:picLocks noChangeAspect="1"/>
+          </p:cNvPicPr>
+          <p:nvPr/>
+        </p:nvPicPr>
+        <p:blipFill>
+          <a:blip r:embed="rId3"/>
+          <a:stretch>
+            <a:fillRect/>
+          </a:stretch>
+        </p:blipFill>
+        <p:spPr>
+          <a:xfrm>
+            <a:off x="6210147" y="1188720"/>
+            <a:ext cx="5615787" cy="3509867"/>
+          </a:xfrm>
+          <a:prstGeom prst="rect">
+            <a:avLst/>
+          </a:prstGeom>
+        </p:spPr>
+      </p:pic>
+      <p:sp>
+        <p:nvSpPr>
+          <p:cNvPr id="6" name="TextBox 5"/>
+          <p:cNvSpPr txBox="1"/>
+          <p:nvPr/>
+        </p:nvSpPr>
+        <p:spPr>
+          <a:xfrm>
+            <a:off x="365760" y="6172200"/>
+            <a:ext cx="11460175" cy="457200"/>
+          </a:xfrm>
+          <a:prstGeom prst="rect">
+            <a:avLst/>
+          </a:prstGeom>
+          <a:noFill/>
+        </p:spPr>
+        <p:txBody>
+          <a:bodyPr wrap="none">
+            <a:spAutoFit/>
+          </a:bodyPr>
+          <a:lstStyle/>
+          <a:p>
+            <a:r>
+              <a:rPr sz="1400">
+                <a:solidFill>
+                  <a:srgbClr val="475569"/>
+                </a:solidFill>
+              </a:rPr>
+              <a:t>Left: Prometheus Targets, both backend pods UP. Right: Grafana dashboard with live traffic.</a:t>
+            </a:r>
+          </a:p>
+        </p:txBody>
+      </p:sp>
+      <p:sp>
+        <p:nvSpPr>
+          <p:cNvPr id="7" name="TextBox 6"/>
+          <p:cNvSpPr txBox="1"/>
+          <p:nvPr/>
+        </p:nvSpPr>
+        <p:spPr>
+          <a:xfrm>
+            <a:off x="365760" y="6446520"/>
+            <a:ext cx="11460175" cy="320040"/>
+          </a:xfrm>
+          <a:prstGeom prst="rect">
+            <a:avLst/>
+          </a:prstGeom>
+          <a:noFill/>
+        </p:spPr>
+        <p:txBody>
+          <a:bodyPr wrap="none">
+            <a:spAutoFit/>
+          </a:bodyPr>
+          <a:lstStyle/>
+          <a:p>
+            <a:r>
+              <a:rPr sz="1100">
+                <a:solidFill>
+                  <a:srgbClr val="94A3B8"/>
+                </a:solidFill>
+              </a:rPr>
+              <a:t>InvenPilot · DevSecOps Final Capstone · Gaurav Kumar          14 / 14</a:t>
             </a:r>
           </a:p>
         </p:txBody>
@@ -4305,7 +5209,7 @@
                 </a:solidFill>
                 <a:latin typeface="Calibri"/>
               </a:rPr>
-              <a:t>2 / 10</a:t>
+              <a:t>2 / 14</a:t>
             </a:r>
           </a:p>
         </p:txBody>
@@ -5021,7 +5925,7 @@
                 </a:solidFill>
                 <a:latin typeface="Calibri"/>
               </a:rPr>
-              <a:t>3 / 10</a:t>
+              <a:t>3 / 14</a:t>
             </a:r>
           </a:p>
         </p:txBody>
@@ -6048,7 +6952,7 @@
                 </a:solidFill>
                 <a:latin typeface="Calibri"/>
               </a:rPr>
-              <a:t>4 / 10</a:t>
+              <a:t>4 / 14</a:t>
             </a:r>
           </a:p>
         </p:txBody>
@@ -7604,7 +8508,7 @@
                 </a:solidFill>
                 <a:latin typeface="Calibri"/>
               </a:rPr>
-              <a:t>5 / 10</a:t>
+              <a:t>5 / 14</a:t>
             </a:r>
           </a:p>
         </p:txBody>
@@ -8394,7 +9298,7 @@
                 </a:solidFill>
                 <a:latin typeface="Calibri"/>
               </a:rPr>
-              <a:t>6 / 10</a:t>
+              <a:t>6 / 14</a:t>
             </a:r>
           </a:p>
         </p:txBody>
@@ -9013,7 +9917,7 @@
                 </a:solidFill>
                 <a:latin typeface="Calibri"/>
               </a:rPr>
-              <a:t>7 / 10</a:t>
+              <a:t>7 / 14</a:t>
             </a:r>
           </a:p>
         </p:txBody>
@@ -9813,7 +10717,7 @@
                 </a:solidFill>
                 <a:latin typeface="Calibri"/>
               </a:rPr>
-              <a:t>8 / 10</a:t>
+              <a:t>8 / 14</a:t>
             </a:r>
           </a:p>
         </p:txBody>
@@ -10427,7 +11331,7 @@
                 </a:solidFill>
                 <a:latin typeface="Calibri"/>
               </a:rPr>
-              <a:t>9 / 10</a:t>
+              <a:t>9 / 14</a:t>
             </a:r>
           </a:p>
         </p:txBody>

</xml_diff>

<commit_message>
revert: restore the StockPilot project name everywhere; repository stays invenpilot-devsecops
</commit_message>
<xml_diff>
--- a/demo/slides.pptx
+++ b/demo/slides.pptx
@@ -3219,7 +3219,7 @@
                 </a:solidFill>
                 <a:latin typeface="Calibri"/>
               </a:rPr>
-              <a:t>InvenPilot — Inventory Management</a:t>
+              <a:t>StockPilot — Inventory Management</a:t>
             </a:r>
           </a:p>
         </p:txBody>
@@ -3544,7 +3544,7 @@
                 </a:solidFill>
                 <a:latin typeface="Calibri"/>
               </a:rPr>
-              <a:t>InvenPilot · DevSecOps Final Capstone · Gaurav Kumar</a:t>
+              <a:t>StockPilot · DevSecOps Final Capstone · Gaurav Kumar</a:t>
             </a:r>
           </a:p>
         </p:txBody>
@@ -4098,7 +4098,7 @@
                 </a:solidFill>
                 <a:latin typeface="Calibri"/>
               </a:rPr>
-              <a:t>InvenPilot — DevSecOps Final Capstone · Gaurav Kumar</a:t>
+              <a:t>StockPilot — DevSecOps Final Capstone · Gaurav Kumar</a:t>
             </a:r>
           </a:p>
         </p:txBody>
@@ -4323,7 +4323,7 @@
                   <a:srgbClr val="94A3B8"/>
                 </a:solidFill>
               </a:rPr>
-              <a:t>InvenPilot · DevSecOps Final Capstone · Gaurav Kumar          11 / 14</a:t>
+              <a:t>StockPilot · DevSecOps Final Capstone · Gaurav Kumar          11 / 14</a:t>
             </a:r>
           </a:p>
         </p:txBody>
@@ -4548,7 +4548,7 @@
                   <a:srgbClr val="94A3B8"/>
                 </a:solidFill>
               </a:rPr>
-              <a:t>InvenPilot · DevSecOps Final Capstone · Gaurav Kumar          12 / 14</a:t>
+              <a:t>StockPilot · DevSecOps Final Capstone · Gaurav Kumar          12 / 14</a:t>
             </a:r>
           </a:p>
         </p:txBody>
@@ -4773,7 +4773,7 @@
                   <a:srgbClr val="94A3B8"/>
                 </a:solidFill>
               </a:rPr>
-              <a:t>InvenPilot · DevSecOps Final Capstone · Gaurav Kumar          13 / 14</a:t>
+              <a:t>StockPilot · DevSecOps Final Capstone · Gaurav Kumar          13 / 14</a:t>
             </a:r>
           </a:p>
         </p:txBody>
@@ -4998,7 +4998,7 @@
                   <a:srgbClr val="94A3B8"/>
                 </a:solidFill>
               </a:rPr>
-              <a:t>InvenPilot · DevSecOps Final Capstone · Gaurav Kumar          14 / 14</a:t>
+              <a:t>StockPilot · DevSecOps Final Capstone · Gaurav Kumar          14 / 14</a:t>
             </a:r>
           </a:p>
         </p:txBody>
@@ -5174,7 +5174,7 @@
                 </a:solidFill>
                 <a:latin typeface="Calibri"/>
               </a:rPr>
-              <a:t>InvenPilot · DevSecOps Final Capstone · Gaurav Kumar</a:t>
+              <a:t>StockPilot · DevSecOps Final Capstone · Gaurav Kumar</a:t>
             </a:r>
           </a:p>
         </p:txBody>
@@ -5890,7 +5890,7 @@
                 </a:solidFill>
                 <a:latin typeface="Calibri"/>
               </a:rPr>
-              <a:t>InvenPilot · DevSecOps Final Capstone · Gaurav Kumar</a:t>
+              <a:t>StockPilot · DevSecOps Final Capstone · Gaurav Kumar</a:t>
             </a:r>
           </a:p>
         </p:txBody>
@@ -6917,7 +6917,7 @@
                 </a:solidFill>
                 <a:latin typeface="Calibri"/>
               </a:rPr>
-              <a:t>InvenPilot · DevSecOps Final Capstone · Gaurav Kumar</a:t>
+              <a:t>StockPilot · DevSecOps Final Capstone · Gaurav Kumar</a:t>
             </a:r>
           </a:p>
         </p:txBody>
@@ -7478,7 +7478,7 @@
                 </a:solidFill>
                 <a:latin typeface="Calibri"/>
               </a:rPr>
-              <a:t>AWS EKS  —  Terraform-provisioned VPC (2 public + 2 private subnets, NAT)   ·   namespace: invenpilot</a:t>
+              <a:t>AWS EKS  —  Terraform-provisioned VPC (2 public + 2 private subnets, NAT)   ·   namespace: stockpilot</a:t>
             </a:r>
           </a:p>
         </p:txBody>
@@ -8048,7 +8048,7 @@
                 </a:solidFill>
                 <a:latin typeface="Calibri"/>
               </a:rPr>
-              <a:t>InvenPilot dashboard</a:t>
+              <a:t>StockPilot dashboard</a:t>
             </a:r>
           </a:p>
         </p:txBody>
@@ -8473,7 +8473,7 @@
                 </a:solidFill>
                 <a:latin typeface="Calibri"/>
               </a:rPr>
-              <a:t>InvenPilot · DevSecOps Final Capstone · Gaurav Kumar</a:t>
+              <a:t>StockPilot · DevSecOps Final Capstone · Gaurav Kumar</a:t>
             </a:r>
           </a:p>
         </p:txBody>
@@ -8967,7 +8967,7 @@
                 </a:solidFill>
                 <a:latin typeface="Calibri"/>
               </a:rPr>
-              <a:t>write SHA into helm/invenpilot/values.yaml</a:t>
+              <a:t>write SHA into helm/stockpilot/values.yaml</a:t>
             </a:r>
           </a:p>
           <a:p>
@@ -9036,7 +9036,7 @@
                 </a:solidFill>
                 <a:latin typeface="Calibri"/>
               </a:rPr>
-              <a:t>Images: ghcr.io/gaurakumar-s/invenpilot-backend:&lt;git-sha&gt; and invenpilot-frontend:&lt;git-sha&gt; — no "latest" tag</a:t>
+              <a:t>Images: ghcr.io/gaurakumar-s/stockpilot-backend:&lt;git-sha&gt; and stockpilot-frontend:&lt;git-sha&gt; — no "latest" tag</a:t>
             </a:r>
           </a:p>
           <a:p>
@@ -9263,7 +9263,7 @@
                 </a:solidFill>
                 <a:latin typeface="Calibri"/>
               </a:rPr>
-              <a:t>InvenPilot · DevSecOps Final Capstone · Gaurav Kumar</a:t>
+              <a:t>StockPilot · DevSecOps Final Capstone · Gaurav Kumar</a:t>
             </a:r>
           </a:p>
         </p:txBody>
@@ -9882,7 +9882,7 @@
                 </a:solidFill>
                 <a:latin typeface="Calibri"/>
               </a:rPr>
-              <a:t>InvenPilot · DevSecOps Final Capstone · Gaurav Kumar</a:t>
+              <a:t>StockPilot · DevSecOps Final Capstone · Gaurav Kumar</a:t>
             </a:r>
           </a:p>
         </p:txBody>
@@ -10682,7 +10682,7 @@
                 </a:solidFill>
                 <a:latin typeface="Calibri"/>
               </a:rPr>
-              <a:t>InvenPilot · DevSecOps Final Capstone · Gaurav Kumar</a:t>
+              <a:t>StockPilot · DevSecOps Final Capstone · Gaurav Kumar</a:t>
             </a:r>
           </a:p>
         </p:txBody>
@@ -10752,7 +10752,7 @@
                 </a:solidFill>
                 <a:latin typeface="Calibri"/>
               </a:rPr>
-              <a:t>Helm chart — helm/invenpilot</a:t>
+              <a:t>Helm chart — helm/stockpilot</a:t>
             </a:r>
           </a:p>
         </p:txBody>
@@ -11084,7 +11084,7 @@
                 </a:solidFill>
                 <a:latin typeface="Menlo"/>
               </a:rPr>
-              <a:t>$ kubectl get pods,svc,ingress -n invenpilot</a:t>
+              <a:t>$ kubectl get pods,svc,ingress -n stockpilot</a:t>
             </a:r>
           </a:p>
           <a:p>
@@ -11096,7 +11096,7 @@
                 </a:solidFill>
                 <a:latin typeface="Menlo"/>
               </a:rPr>
-              <a:t>$ helm list -n invenpilot</a:t>
+              <a:t>$ helm list -n stockpilot</a:t>
             </a:r>
           </a:p>
           <a:p>
@@ -11108,7 +11108,7 @@
                 </a:solidFill>
                 <a:latin typeface="Menlo"/>
               </a:rPr>
-              <a:t>$ kubectl get hpa -n invenpilot</a:t>
+              <a:t>$ kubectl get hpa -n stockpilot</a:t>
             </a:r>
           </a:p>
           <a:p>
@@ -11120,7 +11120,7 @@
                 </a:solidFill>
                 <a:latin typeface="Menlo"/>
               </a:rPr>
-              <a:t>$ argocd app get invenpilot</a:t>
+              <a:t>$ argocd app get stockpilot</a:t>
             </a:r>
           </a:p>
         </p:txBody>
@@ -11296,7 +11296,7 @@
                 </a:solidFill>
                 <a:latin typeface="Calibri"/>
               </a:rPr>
-              <a:t>InvenPilot · DevSecOps Final Capstone · Gaurav Kumar</a:t>
+              <a:t>StockPilot · DevSecOps Final Capstone · Gaurav Kumar</a:t>
             </a:r>
           </a:p>
         </p:txBody>
@@ -11854,7 +11854,7 @@
                 </a:solidFill>
                 <a:latin typeface="Calibri"/>
               </a:rPr>
-              <a:t>Grafana — "InvenPilot — Application Metrics"</a:t>
+              <a:t>Grafana — "StockPilot — Application Metrics"</a:t>
             </a:r>
           </a:p>
         </p:txBody>

</xml_diff>